<commit_message>
Add Sayeret Nahal emblem to the lecture deck
Co-Authored-By: Claude Fable 5.1 <noreply@anthropic.com>
Claude-Session: https://claude.ai/code/session_01VJ4ffGR4QBf998EQw4XNfv
</commit_message>
<xml_diff>
--- a/presentation/hanoch-7-10.pptx
+++ b/presentation/hanoch-7-10.pptx
@@ -11731,6 +11731,30 @@
           </a:p>
         </p:txBody>
       </p:sp>
+      <p:pic>
+        <p:nvPicPr>
+          <p:cNvPr id="6" name="Image 0" descr="nahal-sand.png">    </p:cNvPr>
+          <p:cNvPicPr>
+            <a:picLocks noChangeAspect="1"/>
+          </p:cNvPicPr>
+          <p:nvPr/>
+        </p:nvPicPr>
+        <p:blipFill>
+          <a:blip r:embed="rId1"/>
+          <a:stretch>
+            <a:fillRect/>
+          </a:stretch>
+        </p:blipFill>
+        <p:spPr>
+          <a:xfrm>
+            <a:off x="914400" y="1463040"/>
+            <a:ext cx="3840480" cy="2107166"/>
+          </a:xfrm>
+          <a:prstGeom prst="rect">
+            <a:avLst/>
+          </a:prstGeom>
+        </p:spPr>
+      </p:pic>
     </p:spTree>
   </p:cSld>
   <p:clrMapOvr>
@@ -11772,7 +11796,7 @@
         <p:spPr>
           <a:xfrm>
             <a:off x="822960" y="548640"/>
-            <a:ext cx="10545775" cy="914400"/>
+            <a:ext cx="8534095" cy="914400"/>
           </a:xfrm>
           <a:prstGeom prst="rect">
             <a:avLst/>
@@ -11802,9 +11826,33 @@
           </a:p>
         </p:txBody>
       </p:sp>
-      <p:sp>
-        <p:nvSpPr>
-          <p:cNvPr id="3" name="Shape 1"/>
+      <p:pic>
+        <p:nvPicPr>
+          <p:cNvPr id="3" name="Image 0" descr="nahal-dark.png">    </p:cNvPr>
+          <p:cNvPicPr>
+            <a:picLocks noChangeAspect="1"/>
+          </p:cNvPicPr>
+          <p:nvPr/>
+        </p:nvPicPr>
+        <p:blipFill>
+          <a:blip r:embed="rId1"/>
+          <a:stretch>
+            <a:fillRect/>
+          </a:stretch>
+        </p:blipFill>
+        <p:spPr>
+          <a:xfrm>
+            <a:off x="822960" y="320040"/>
+            <a:ext cx="2468880" cy="1354607"/>
+          </a:xfrm>
+          <a:prstGeom prst="rect">
+            <a:avLst/>
+          </a:prstGeom>
+        </p:spPr>
+      </p:pic>
+      <p:sp>
+        <p:nvSpPr>
+          <p:cNvPr id="4" name="Shape 1"/>
           <p:cNvSpPr/>
           <p:nvPr/>
         </p:nvSpPr>
@@ -11831,14 +11879,14 @@
       </p:sp>
       <p:pic>
         <p:nvPicPr>
-          <p:cNvPr id="4" name="Image 0" descr="preencoded.png">    </p:cNvPr>
+          <p:cNvPr id="5" name="Image 1" descr="preencoded.png">    </p:cNvPr>
           <p:cNvPicPr>
             <a:picLocks noChangeAspect="1"/>
           </p:cNvPicPr>
           <p:nvPr/>
         </p:nvPicPr>
         <p:blipFill>
-          <a:blip r:embed="rId1"/>
+          <a:blip r:embed="rId2"/>
           <a:stretch>
             <a:fillRect/>
           </a:stretch>
@@ -11855,7 +11903,7 @@
       </p:pic>
       <p:sp>
         <p:nvSpPr>
-          <p:cNvPr id="5" name="Text 2"/>
+          <p:cNvPr id="6" name="Text 2"/>
           <p:cNvSpPr txBox="1"/>
           <p:nvPr/>
         </p:nvSpPr>
@@ -11894,7 +11942,7 @@
       </p:sp>
       <p:sp>
         <p:nvSpPr>
-          <p:cNvPr id="6" name="Shape 3"/>
+          <p:cNvPr id="7" name="Shape 3"/>
           <p:cNvSpPr/>
           <p:nvPr/>
         </p:nvSpPr>
@@ -11921,7 +11969,7 @@
       </p:sp>
       <p:sp>
         <p:nvSpPr>
-          <p:cNvPr id="7" name="Shape 4"/>
+          <p:cNvPr id="8" name="Shape 4"/>
           <p:cNvSpPr/>
           <p:nvPr/>
         </p:nvSpPr>
@@ -11946,14 +11994,14 @@
       </p:sp>
       <p:pic>
         <p:nvPicPr>
-          <p:cNvPr id="8" name="Image 1" descr="preencoded.png">    </p:cNvPr>
+          <p:cNvPr id="9" name="Image 2" descr="preencoded.png">    </p:cNvPr>
           <p:cNvPicPr>
             <a:picLocks noChangeAspect="1"/>
           </p:cNvPicPr>
           <p:nvPr/>
         </p:nvPicPr>
         <p:blipFill>
-          <a:blip r:embed="rId2"/>
+          <a:blip r:embed="rId3"/>
           <a:stretch>
             <a:fillRect/>
           </a:stretch>
@@ -11970,7 +12018,7 @@
       </p:pic>
       <p:sp>
         <p:nvSpPr>
-          <p:cNvPr id="9" name="Text 5"/>
+          <p:cNvPr id="10" name="Text 5"/>
           <p:cNvSpPr txBox="1"/>
           <p:nvPr/>
         </p:nvSpPr>
@@ -12009,7 +12057,7 @@
       </p:sp>
       <p:sp>
         <p:nvSpPr>
-          <p:cNvPr id="10" name="Text 6"/>
+          <p:cNvPr id="11" name="Text 6"/>
           <p:cNvSpPr txBox="1"/>
           <p:nvPr/>
         </p:nvSpPr>
@@ -12048,7 +12096,7 @@
       </p:sp>
       <p:sp>
         <p:nvSpPr>
-          <p:cNvPr id="11" name="Shape 7"/>
+          <p:cNvPr id="12" name="Shape 7"/>
           <p:cNvSpPr/>
           <p:nvPr/>
         </p:nvSpPr>
@@ -12075,7 +12123,7 @@
       </p:sp>
       <p:sp>
         <p:nvSpPr>
-          <p:cNvPr id="12" name="Shape 8"/>
+          <p:cNvPr id="13" name="Shape 8"/>
           <p:cNvSpPr/>
           <p:nvPr/>
         </p:nvSpPr>
@@ -12100,14 +12148,14 @@
       </p:sp>
       <p:pic>
         <p:nvPicPr>
-          <p:cNvPr id="13" name="Image 2" descr="preencoded.png">    </p:cNvPr>
+          <p:cNvPr id="14" name="Image 3" descr="preencoded.png">    </p:cNvPr>
           <p:cNvPicPr>
             <a:picLocks noChangeAspect="1"/>
           </p:cNvPicPr>
           <p:nvPr/>
         </p:nvPicPr>
         <p:blipFill>
-          <a:blip r:embed="rId3"/>
+          <a:blip r:embed="rId4"/>
           <a:stretch>
             <a:fillRect/>
           </a:stretch>
@@ -12124,7 +12172,7 @@
       </p:pic>
       <p:sp>
         <p:nvSpPr>
-          <p:cNvPr id="14" name="Text 9"/>
+          <p:cNvPr id="15" name="Text 9"/>
           <p:cNvSpPr txBox="1"/>
           <p:nvPr/>
         </p:nvSpPr>
@@ -12163,7 +12211,7 @@
       </p:sp>
       <p:sp>
         <p:nvSpPr>
-          <p:cNvPr id="15" name="Text 10"/>
+          <p:cNvPr id="16" name="Text 10"/>
           <p:cNvSpPr txBox="1"/>
           <p:nvPr/>
         </p:nvSpPr>
@@ -12202,7 +12250,7 @@
       </p:sp>
       <p:sp>
         <p:nvSpPr>
-          <p:cNvPr id="16" name="Shape 11"/>
+          <p:cNvPr id="17" name="Shape 11"/>
           <p:cNvSpPr/>
           <p:nvPr/>
         </p:nvSpPr>
@@ -12229,7 +12277,7 @@
       </p:sp>
       <p:sp>
         <p:nvSpPr>
-          <p:cNvPr id="17" name="Shape 12"/>
+          <p:cNvPr id="18" name="Shape 12"/>
           <p:cNvSpPr/>
           <p:nvPr/>
         </p:nvSpPr>
@@ -12254,14 +12302,14 @@
       </p:sp>
       <p:pic>
         <p:nvPicPr>
-          <p:cNvPr id="18" name="Image 3" descr="preencoded.png">    </p:cNvPr>
+          <p:cNvPr id="19" name="Image 4" descr="preencoded.png">    </p:cNvPr>
           <p:cNvPicPr>
             <a:picLocks noChangeAspect="1"/>
           </p:cNvPicPr>
           <p:nvPr/>
         </p:nvPicPr>
         <p:blipFill>
-          <a:blip r:embed="rId4"/>
+          <a:blip r:embed="rId5"/>
           <a:stretch>
             <a:fillRect/>
           </a:stretch>
@@ -12278,7 +12326,7 @@
       </p:pic>
       <p:sp>
         <p:nvSpPr>
-          <p:cNvPr id="19" name="Text 13"/>
+          <p:cNvPr id="20" name="Text 13"/>
           <p:cNvSpPr txBox="1"/>
           <p:nvPr/>
         </p:nvSpPr>
@@ -12317,7 +12365,7 @@
       </p:sp>
       <p:sp>
         <p:nvSpPr>
-          <p:cNvPr id="20" name="Text 14"/>
+          <p:cNvPr id="21" name="Text 14"/>
           <p:cNvSpPr txBox="1"/>
           <p:nvPr/>
         </p:nvSpPr>
@@ -12356,7 +12404,7 @@
       </p:sp>
       <p:sp>
         <p:nvSpPr>
-          <p:cNvPr id="21" name="Shape 15"/>
+          <p:cNvPr id="22" name="Shape 15"/>
           <p:cNvSpPr/>
           <p:nvPr/>
         </p:nvSpPr>
@@ -12383,7 +12431,7 @@
       </p:sp>
       <p:sp>
         <p:nvSpPr>
-          <p:cNvPr id="22" name="Shape 16"/>
+          <p:cNvPr id="23" name="Shape 16"/>
           <p:cNvSpPr/>
           <p:nvPr/>
         </p:nvSpPr>
@@ -12408,14 +12456,14 @@
       </p:sp>
       <p:pic>
         <p:nvPicPr>
-          <p:cNvPr id="23" name="Image 4" descr="preencoded.png">    </p:cNvPr>
+          <p:cNvPr id="24" name="Image 5" descr="preencoded.png">    </p:cNvPr>
           <p:cNvPicPr>
             <a:picLocks noChangeAspect="1"/>
           </p:cNvPicPr>
           <p:nvPr/>
         </p:nvPicPr>
         <p:blipFill>
-          <a:blip r:embed="rId5"/>
+          <a:blip r:embed="rId6"/>
           <a:stretch>
             <a:fillRect/>
           </a:stretch>
@@ -12432,7 +12480,7 @@
       </p:pic>
       <p:sp>
         <p:nvSpPr>
-          <p:cNvPr id="24" name="Text 17"/>
+          <p:cNvPr id="25" name="Text 17"/>
           <p:cNvSpPr txBox="1"/>
           <p:nvPr/>
         </p:nvSpPr>
@@ -12471,7 +12519,7 @@
       </p:sp>
       <p:sp>
         <p:nvSpPr>
-          <p:cNvPr id="25" name="Text 18"/>
+          <p:cNvPr id="26" name="Text 18"/>
           <p:cNvSpPr txBox="1"/>
           <p:nvPr/>
         </p:nvSpPr>
@@ -12510,7 +12558,7 @@
       </p:sp>
       <p:sp>
         <p:nvSpPr>
-          <p:cNvPr id="26" name="Text 19"/>
+          <p:cNvPr id="27" name="Text 19"/>
           <p:cNvSpPr txBox="1"/>
           <p:nvPr/>
         </p:nvSpPr>

</xml_diff>